<commit_message>
Explain loss symbols directly on future work slide
</commit_message>
<xml_diff>
--- a/presentations/future_work_yaw_supervision_cn.pptx
+++ b/presentations/future_work_yaw_supervision_cn.pptx
@@ -4101,7 +4101,7 @@
               <a:spcAft>
                 <a:spcPts val="700"/>
               </a:spcAft>
-              <a:defRPr sz="1500" b="1">
+              <a:defRPr sz="1400" b="1">
                 <a:solidFill>
                   <a:srgbClr val="142B46"/>
                 </a:solidFill>
@@ -4109,7 +4109,7 @@
               </a:defRPr>
             </a:pPr>
             <a:r>
-              <a:t>损失：L方向</a:t>
+              <a:t>总损失 = 方向损失</a:t>
             </a:r>
           </a:p>
         </p:txBody>
@@ -4122,7 +4122,7 @@
         </p:nvSpPr>
         <p:spPr>
           <a:xfrm>
-            <a:off x="850392" y="4178808"/>
+            <a:off x="850392" y="4297680"/>
             <a:ext cx="3108960" cy="246888"/>
           </a:xfrm>
           <a:prstGeom prst="rect">
@@ -4162,7 +4162,7 @@
         </p:nvSpPr>
         <p:spPr>
           <a:xfrm>
-            <a:off x="850392" y="4526280"/>
+            <a:off x="850392" y="4608576"/>
             <a:ext cx="3108960" cy="228600"/>
           </a:xfrm>
           <a:prstGeom prst="rect">
@@ -4282,8 +4282,8 @@
         </p:nvSpPr>
         <p:spPr>
           <a:xfrm>
-            <a:off x="4535424" y="3794760"/>
-            <a:ext cx="3108960" cy="274320"/>
+            <a:off x="4535424" y="3712463"/>
+            <a:ext cx="3108960" cy="530352"/>
           </a:xfrm>
           <a:prstGeom prst="rect">
             <a:avLst/>
@@ -4301,7 +4301,7 @@
               <a:spcAft>
                 <a:spcPts val="700"/>
               </a:spcAft>
-              <a:defRPr sz="1400" b="1">
+              <a:defRPr sz="1200" b="1">
                 <a:solidFill>
                   <a:srgbClr val="142B46"/>
                 </a:solidFill>
@@ -4309,7 +4309,23 @@
               </a:defRPr>
             </a:pPr>
             <a:r>
-              <a:t>损失：L方向 + λ转角 L转角</a:t>
+              <a:t>总损失 = 方向损失</a:t>
+            </a:r>
+          </a:p>
+          <a:p>
+            <a:pPr>
+              <a:spcAft>
+                <a:spcPts val="700"/>
+              </a:spcAft>
+              <a:defRPr sz="1200" b="1">
+                <a:solidFill>
+                  <a:srgbClr val="142B46"/>
+                </a:solidFill>
+                <a:latin typeface="Noto Sans CJK SC"/>
+              </a:defRPr>
+            </a:pPr>
+            <a:r>
+              <a:t>+ 转角权重 × 转角损失</a:t>
             </a:r>
           </a:p>
         </p:txBody>
@@ -4322,7 +4338,7 @@
         </p:nvSpPr>
         <p:spPr>
           <a:xfrm>
-            <a:off x="4535424" y="4178808"/>
+            <a:off x="4535424" y="4297680"/>
             <a:ext cx="3108960" cy="246888"/>
           </a:xfrm>
           <a:prstGeom prst="rect">
@@ -4362,7 +4378,7 @@
         </p:nvSpPr>
         <p:spPr>
           <a:xfrm>
-            <a:off x="4535424" y="4526280"/>
+            <a:off x="4535424" y="4608576"/>
             <a:ext cx="3108960" cy="228600"/>
           </a:xfrm>
           <a:prstGeom prst="rect">
@@ -4482,8 +4498,8 @@
         </p:nvSpPr>
         <p:spPr>
           <a:xfrm>
-            <a:off x="8220456" y="3794760"/>
-            <a:ext cx="3108960" cy="274320"/>
+            <a:off x="8220456" y="3712463"/>
+            <a:ext cx="3108960" cy="530352"/>
           </a:xfrm>
           <a:prstGeom prst="rect">
             <a:avLst/>
@@ -4501,7 +4517,7 @@
               <a:spcAft>
                 <a:spcPts val="700"/>
               </a:spcAft>
-              <a:defRPr sz="1400" b="1">
+              <a:defRPr sz="1200" b="1">
                 <a:solidFill>
                   <a:srgbClr val="142B46"/>
                 </a:solidFill>
@@ -4509,7 +4525,23 @@
               </a:defRPr>
             </a:pPr>
             <a:r>
-              <a:t>损失：LB + λ积分 L积分</a:t>
+              <a:t>总损失 = B 组总损失</a:t>
+            </a:r>
+          </a:p>
+          <a:p>
+            <a:pPr>
+              <a:spcAft>
+                <a:spcPts val="700"/>
+              </a:spcAft>
+              <a:defRPr sz="1200" b="1">
+                <a:solidFill>
+                  <a:srgbClr val="142B46"/>
+                </a:solidFill>
+                <a:latin typeface="Noto Sans CJK SC"/>
+              </a:defRPr>
+            </a:pPr>
+            <a:r>
+              <a:t>+ 积分权重 × 积分方向损失</a:t>
             </a:r>
           </a:p>
         </p:txBody>
@@ -4522,7 +4554,7 @@
         </p:nvSpPr>
         <p:spPr>
           <a:xfrm>
-            <a:off x="8220456" y="4178808"/>
+            <a:off x="8220456" y="4297680"/>
             <a:ext cx="3108960" cy="246888"/>
           </a:xfrm>
           <a:prstGeom prst="rect">
@@ -4562,7 +4594,7 @@
         </p:nvSpPr>
         <p:spPr>
           <a:xfrm>
-            <a:off x="8220456" y="4526280"/>
+            <a:off x="8220456" y="4608576"/>
             <a:ext cx="3108960" cy="228600"/>
           </a:xfrm>
           <a:prstGeom prst="rect">
@@ -4596,14 +4628,60 @@
       </p:sp>
       <p:sp>
         <p:nvSpPr>
-          <p:cNvPr id="27" name="TextBox 26"/>
+          <p:cNvPr id="27" name="Rounded Rectangle 26"/>
+          <p:cNvSpPr/>
+          <p:nvPr/>
+        </p:nvSpPr>
+        <p:spPr>
+          <a:xfrm>
+            <a:off x="667512" y="4992624"/>
+            <a:ext cx="10853928" cy="850392"/>
+          </a:xfrm>
+          <a:prstGeom prst="roundRect">
+            <a:avLst>
+              <a:gd name="adj" fmla="val 12000"/>
+            </a:avLst>
+          </a:prstGeom>
+          <a:solidFill>
+            <a:srgbClr val="ECF1F7"/>
+          </a:solidFill>
+          <a:ln>
+            <a:noFill/>
+          </a:ln>
+          <a:effectLst/>
+        </p:spPr>
+        <p:style>
+          <a:lnRef idx="1">
+            <a:schemeClr val="accent1"/>
+          </a:lnRef>
+          <a:fillRef idx="3">
+            <a:schemeClr val="accent1"/>
+          </a:fillRef>
+          <a:effectRef idx="0">
+            <a:schemeClr val="accent1"/>
+          </a:effectRef>
+          <a:fontRef idx="minor">
+            <a:schemeClr val="lt1"/>
+          </a:fontRef>
+        </p:style>
+        <p:txBody>
+          <a:bodyPr rtlCol="0" anchor="ctr"/>
+          <a:lstStyle/>
+          <a:p>
+            <a:pPr algn="ctr"/>
+          </a:p>
+        </p:txBody>
+      </p:sp>
+      <p:sp>
+        <p:nvSpPr>
+          <p:cNvPr id="28" name="TextBox 27"/>
           <p:cNvSpPr txBox="1"/>
           <p:nvPr/>
         </p:nvSpPr>
         <p:spPr>
           <a:xfrm>
-            <a:off x="694944" y="5020056"/>
-            <a:ext cx="10789920" cy="256032"/>
+            <a:off x="841248" y="5074920"/>
+            <a:ext cx="10442448" cy="210312"/>
           </a:xfrm>
           <a:prstGeom prst="rect">
             <a:avLst/>
@@ -4621,7 +4699,47 @@
               <a:spcAft>
                 <a:spcPts val="700"/>
               </a:spcAft>
-              <a:defRPr sz="1200" b="0">
+              <a:defRPr sz="1100" b="1">
+                <a:solidFill>
+                  <a:srgbClr val="142B46"/>
+                </a:solidFill>
+                <a:latin typeface="Noto Sans CJK SC"/>
+              </a:defRPr>
+            </a:pPr>
+            <a:r>
+              <a:t>L（损失）：训练时衡量预测与真值的差异，模型通过减小它来学习。</a:t>
+            </a:r>
+          </a:p>
+        </p:txBody>
+      </p:sp>
+      <p:sp>
+        <p:nvSpPr>
+          <p:cNvPr id="29" name="TextBox 28"/>
+          <p:cNvSpPr txBox="1"/>
+          <p:nvPr/>
+        </p:nvSpPr>
+        <p:spPr>
+          <a:xfrm>
+            <a:off x="841248" y="5330952"/>
+            <a:ext cx="10442448" cy="210312"/>
+          </a:xfrm>
+          <a:prstGeom prst="rect">
+            <a:avLst/>
+          </a:prstGeom>
+          <a:noFill/>
+          <a:effectLst/>
+        </p:spPr>
+        <p:txBody>
+          <a:bodyPr wrap="none" lIns="0" rIns="0" tIns="0" bIns="0">
+            <a:spAutoFit/>
+          </a:bodyPr>
+          <a:lstStyle/>
+          <a:p>
+            <a:pPr>
+              <a:spcAft>
+                <a:spcPts val="700"/>
+              </a:spcAft>
+              <a:defRPr sz="1050" b="0">
                 <a:solidFill>
                   <a:srgbClr val="62748A"/>
                 </a:solidFill>
@@ -4629,57 +4747,21 @@
               </a:defRPr>
             </a:pPr>
             <a:r>
-              <a:t>监督怎么给：转角预测对齐真实相邻姿态差；积分方向对齐“当前点 → 第 8 步真实位置”的方向。</a:t>
-            </a:r>
-          </a:p>
-        </p:txBody>
-      </p:sp>
-      <p:cxnSp>
-        <p:nvCxnSpPr>
-          <p:cNvPr id="28" name="Connector 27"/>
-          <p:cNvCxnSpPr/>
-          <p:nvPr/>
-        </p:nvCxnSpPr>
-        <p:spPr>
-          <a:xfrm>
-            <a:off x="685800" y="5468112"/>
-            <a:ext cx="10817352" cy="0"/>
-          </a:xfrm>
-          <a:prstGeom prst="line">
-            <a:avLst/>
-          </a:prstGeom>
-          <a:ln w="12700">
-            <a:solidFill>
-              <a:srgbClr val="DCE5EF"/>
-            </a:solidFill>
-          </a:ln>
-          <a:effectLst/>
-        </p:spPr>
-        <p:style>
-          <a:lnRef idx="2">
-            <a:schemeClr val="accent1"/>
-          </a:lnRef>
-          <a:fillRef idx="0">
-            <a:schemeClr val="accent1"/>
-          </a:fillRef>
-          <a:effectRef idx="0">
-            <a:schemeClr val="accent1"/>
-          </a:effectRef>
-          <a:fontRef idx="minor">
-            <a:schemeClr val="tx1"/>
-          </a:fontRef>
-        </p:style>
-      </p:cxnSp>
-      <p:sp>
-        <p:nvSpPr>
-          <p:cNvPr id="29" name="TextBox 28"/>
+              <a:t>λ（lambda，辅助权重）：决定辅助任务的影响；例如“方向损失 + 0.3 × 转角损失”，转角权重就是 0.3。</a:t>
+            </a:r>
+          </a:p>
+        </p:txBody>
+      </p:sp>
+      <p:sp>
+        <p:nvSpPr>
+          <p:cNvPr id="30" name="TextBox 29"/>
           <p:cNvSpPr txBox="1"/>
           <p:nvPr/>
         </p:nvSpPr>
         <p:spPr>
           <a:xfrm>
-            <a:off x="694944" y="5623560"/>
-            <a:ext cx="2057400" cy="292608"/>
+            <a:off x="841248" y="5586984"/>
+            <a:ext cx="10442448" cy="210312"/>
           </a:xfrm>
           <a:prstGeom prst="rect">
             <a:avLst/>
@@ -4697,47 +4779,7 @@
               <a:spcAft>
                 <a:spcPts val="700"/>
               </a:spcAft>
-              <a:defRPr sz="1500" b="1">
-                <a:solidFill>
-                  <a:srgbClr val="142B46"/>
-                </a:solidFill>
-                <a:latin typeface="Noto Sans CJK SC"/>
-              </a:defRPr>
-            </a:pPr>
-            <a:r>
-              <a:t>验证顺序与判断标准</a:t>
-            </a:r>
-          </a:p>
-        </p:txBody>
-      </p:sp>
-      <p:sp>
-        <p:nvSpPr>
-          <p:cNvPr id="30" name="TextBox 29"/>
-          <p:cNvSpPr txBox="1"/>
-          <p:nvPr/>
-        </p:nvSpPr>
-        <p:spPr>
-          <a:xfrm>
-            <a:off x="2788920" y="5614416"/>
-            <a:ext cx="8686800" cy="274320"/>
-          </a:xfrm>
-          <a:prstGeom prst="rect">
-            <a:avLst/>
-          </a:prstGeom>
-          <a:noFill/>
-          <a:effectLst/>
-        </p:spPr>
-        <p:txBody>
-          <a:bodyPr wrap="none" lIns="0" rIns="0" tIns="0" bIns="0">
-            <a:spAutoFit/>
-          </a:bodyPr>
-          <a:lstStyle/>
-          <a:p>
-            <a:pPr>
-              <a:spcAft>
-                <a:spcPts val="700"/>
-              </a:spcAft>
-              <a:defRPr sz="1200" b="0">
+              <a:defRPr sz="1050" b="0">
                 <a:solidFill>
                   <a:srgbClr val="62748A"/>
                 </a:solidFill>
@@ -4745,7 +4787,7 @@
               </a:defRPr>
             </a:pPr>
             <a:r>
-              <a:t>先看方向：全体 / 转弯的中位误差、P90、&gt;45° 比例；再看融合收益。</a:t>
+              <a:t>θ（theta，夹角）：此处指积分方向与真实终点方向的夹角；积分方向损失 = 1 − cos θ，夹角为 0 时损失为 0。</a:t>
             </a:r>
           </a:p>
         </p:txBody>
@@ -4758,8 +4800,8 @@
         </p:nvSpPr>
         <p:spPr>
           <a:xfrm>
-            <a:off x="2788920" y="6007608"/>
-            <a:ext cx="8686800" cy="265176"/>
+            <a:off x="694944" y="5989320"/>
+            <a:ext cx="10789920" cy="228600"/>
           </a:xfrm>
           <a:prstGeom prst="rect">
             <a:avLst/>
@@ -4785,7 +4827,7 @@
               </a:defRPr>
             </a:pPr>
             <a:r>
-              <a:t>两种方向分别按各自验证误差选模型；固定评估集合，配对比较并报告不确定性。</a:t>
+              <a:t>监督：转角对齐未来 8 步真实相邻姿态差；积分方向对齐“当前点 → 第 8 步真实位置”的方向。</a:t>
             </a:r>
           </a:p>
         </p:txBody>
@@ -4798,8 +4840,8 @@
         </p:nvSpPr>
         <p:spPr>
           <a:xfrm>
-            <a:off x="685800" y="6446520"/>
-            <a:ext cx="10835640" cy="219456"/>
+            <a:off x="694944" y="6327648"/>
+            <a:ext cx="10789920" cy="228600"/>
           </a:xfrm>
           <a:prstGeom prst="rect">
             <a:avLst/>
@@ -4817,7 +4859,47 @@
               <a:spcAft>
                 <a:spcPts val="700"/>
               </a:spcAft>
-              <a:defRPr sz="1200" b="1">
+              <a:defRPr sz="1100" b="0">
+                <a:solidFill>
+                  <a:srgbClr val="62748A"/>
+                </a:solidFill>
+                <a:latin typeface="Noto Sans CJK SC"/>
+              </a:defRPr>
+            </a:pPr>
+            <a:r>
+              <a:t>验证：先比较全体 / 转弯的中位误差、P90、&gt;45° 比例，再看融合收益；两种方向各按验证误差选模型。</a:t>
+            </a:r>
+          </a:p>
+        </p:txBody>
+      </p:sp>
+      <p:sp>
+        <p:nvSpPr>
+          <p:cNvPr id="33" name="TextBox 32"/>
+          <p:cNvSpPr txBox="1"/>
+          <p:nvPr/>
+        </p:nvSpPr>
+        <p:spPr>
+          <a:xfrm>
+            <a:off x="685800" y="6656832"/>
+            <a:ext cx="10835640" cy="155448"/>
+          </a:xfrm>
+          <a:prstGeom prst="rect">
+            <a:avLst/>
+          </a:prstGeom>
+          <a:noFill/>
+          <a:effectLst/>
+        </p:spPr>
+        <p:txBody>
+          <a:bodyPr wrap="none" lIns="0" rIns="0" tIns="0" bIns="0">
+            <a:spAutoFit/>
+          </a:bodyPr>
+          <a:lstStyle/>
+          <a:p>
+            <a:pPr>
+              <a:spcAft>
+                <a:spcPts val="700"/>
+              </a:spcAft>
+              <a:defRPr sz="900" b="1">
                 <a:solidFill>
                   <a:srgbClr val="148D91"/>
                 </a:solidFill>
@@ -4825,47 +4907,7 @@
               </a:defRPr>
             </a:pPr>
             <a:r>
-              <a:t>预期产出：确定转角是否适合做辅助监督，以及是否值得替换现有推理方向；不预设一定有效。</a:t>
-            </a:r>
-          </a:p>
-        </p:txBody>
-      </p:sp>
-      <p:sp>
-        <p:nvSpPr>
-          <p:cNvPr id="33" name="TextBox 32"/>
-          <p:cNvSpPr txBox="1"/>
-          <p:nvPr/>
-        </p:nvSpPr>
-        <p:spPr>
-          <a:xfrm>
-            <a:off x="685800" y="6711696"/>
-            <a:ext cx="10835640" cy="118872"/>
-          </a:xfrm>
-          <a:prstGeom prst="rect">
-            <a:avLst/>
-          </a:prstGeom>
-          <a:noFill/>
-          <a:effectLst/>
-        </p:spPr>
-        <p:txBody>
-          <a:bodyPr wrap="none" lIns="0" rIns="0" tIns="0" bIns="0">
-            <a:spAutoFit/>
-          </a:bodyPr>
-          <a:lstStyle/>
-          <a:p>
-            <a:pPr>
-              <a:spcAft>
-                <a:spcPts val="700"/>
-              </a:spcAft>
-              <a:defRPr sz="750" b="0">
-                <a:solidFill>
-                  <a:srgbClr val="62748A"/>
-                </a:solidFill>
-                <a:latin typeface="Noto Sans CJK SC"/>
-              </a:defRPr>
-            </a:pPr>
-            <a:r>
-              <a:t>计划设计，尚非实验结论。L转角 为逐步转角回归损失，L积分 为积分方向的余弦损失；LB 为 B 组总损失，λ 为辅助项权重。</a:t>
+              <a:t>计划目标：分别验证转角辅助训练与积分推理，不预设有效；固定评估集合，配对比较并报告不确定性。0.3 为权重示例。</a:t>
             </a:r>
           </a:p>
         </p:txBody>

</xml_diff>